<commit_message>
P088 V02 PPTX 含照片
</commit_message>
<xml_diff>
--- a/P088_robinstech_intro_v02_20p.pptx
+++ b/P088_robinstech_intro_v02_20p.pptx
@@ -24985,9 +24985,33 @@
           </a:p>
         </p:txBody>
       </p:sp>
-      <p:sp>
-        <p:nvSpPr>
-          <p:cNvPr id="10" name="TextBox 9"/>
+      <p:pic>
+        <p:nvPicPr>
+          <p:cNvPr id="10" name="Picture 9" descr="dir_0.png"/>
+          <p:cNvPicPr>
+            <a:picLocks noChangeAspect="1"/>
+          </p:cNvPicPr>
+          <p:nvPr/>
+        </p:nvPicPr>
+        <p:blipFill>
+          <a:blip r:embed="rId2"/>
+          <a:stretch>
+            <a:fillRect/>
+          </a:stretch>
+        </p:blipFill>
+        <p:spPr>
+          <a:xfrm>
+            <a:off x="548640" y="1371600"/>
+            <a:ext cx="1371600" cy="1371600"/>
+          </a:xfrm>
+          <a:prstGeom prst="rect">
+            <a:avLst/>
+          </a:prstGeom>
+        </p:spPr>
+      </p:pic>
+      <p:sp>
+        <p:nvSpPr>
+          <p:cNvPr id="11" name="TextBox 10"/>
           <p:cNvSpPr txBox="1"/>
           <p:nvPr/>
         </p:nvSpPr>
@@ -25022,7 +25046,7 @@
       </p:sp>
       <p:sp>
         <p:nvSpPr>
-          <p:cNvPr id="11" name="TextBox 10"/>
+          <p:cNvPr id="12" name="TextBox 11"/>
           <p:cNvSpPr txBox="1"/>
           <p:nvPr/>
         </p:nvSpPr>
@@ -25057,7 +25081,7 @@
       </p:sp>
       <p:sp>
         <p:nvSpPr>
-          <p:cNvPr id="12" name="Rectangle 11"/>
+          <p:cNvPr id="13" name="Rectangle 12"/>
           <p:cNvSpPr/>
           <p:nvPr/>
         </p:nvSpPr>
@@ -25100,7 +25124,7 @@
       </p:sp>
       <p:sp>
         <p:nvSpPr>
-          <p:cNvPr id="13" name="TextBox 12"/>
+          <p:cNvPr id="14" name="TextBox 13"/>
           <p:cNvSpPr txBox="1"/>
           <p:nvPr/>
         </p:nvSpPr>
@@ -25139,7 +25163,7 @@
       </p:sp>
       <p:sp>
         <p:nvSpPr>
-          <p:cNvPr id="14" name="Rectangle 13"/>
+          <p:cNvPr id="15" name="Rectangle 14"/>
           <p:cNvSpPr/>
           <p:nvPr/>
         </p:nvSpPr>
@@ -25180,9 +25204,33 @@
           </a:p>
         </p:txBody>
       </p:sp>
-      <p:sp>
-        <p:nvSpPr>
-          <p:cNvPr id="15" name="TextBox 14"/>
+      <p:pic>
+        <p:nvPicPr>
+          <p:cNvPr id="16" name="Picture 15" descr="dir_1.png"/>
+          <p:cNvPicPr>
+            <a:picLocks noChangeAspect="1"/>
+          </p:cNvPicPr>
+          <p:nvPr/>
+        </p:nvPicPr>
+        <p:blipFill>
+          <a:blip r:embed="rId3"/>
+          <a:stretch>
+            <a:fillRect/>
+          </a:stretch>
+        </p:blipFill>
+        <p:spPr>
+          <a:xfrm>
+            <a:off x="5257800" y="1371600"/>
+            <a:ext cx="1371600" cy="1371600"/>
+          </a:xfrm>
+          <a:prstGeom prst="rect">
+            <a:avLst/>
+          </a:prstGeom>
+        </p:spPr>
+      </p:pic>
+      <p:sp>
+        <p:nvSpPr>
+          <p:cNvPr id="17" name="TextBox 16"/>
           <p:cNvSpPr txBox="1"/>
           <p:nvPr/>
         </p:nvSpPr>
@@ -25217,7 +25265,7 @@
       </p:sp>
       <p:sp>
         <p:nvSpPr>
-          <p:cNvPr id="16" name="TextBox 15"/>
+          <p:cNvPr id="18" name="TextBox 17"/>
           <p:cNvSpPr txBox="1"/>
           <p:nvPr/>
         </p:nvSpPr>
@@ -25252,7 +25300,7 @@
       </p:sp>
       <p:sp>
         <p:nvSpPr>
-          <p:cNvPr id="17" name="Rectangle 16"/>
+          <p:cNvPr id="19" name="Rectangle 18"/>
           <p:cNvSpPr/>
           <p:nvPr/>
         </p:nvSpPr>
@@ -25295,7 +25343,7 @@
       </p:sp>
       <p:sp>
         <p:nvSpPr>
-          <p:cNvPr id="18" name="TextBox 17"/>
+          <p:cNvPr id="20" name="TextBox 19"/>
           <p:cNvSpPr txBox="1"/>
           <p:nvPr/>
         </p:nvSpPr>
@@ -25334,7 +25382,7 @@
       </p:sp>
       <p:sp>
         <p:nvSpPr>
-          <p:cNvPr id="19" name="Rectangle 18"/>
+          <p:cNvPr id="21" name="Rectangle 20"/>
           <p:cNvSpPr/>
           <p:nvPr/>
         </p:nvSpPr>
@@ -25375,9 +25423,33 @@
           </a:p>
         </p:txBody>
       </p:sp>
-      <p:sp>
-        <p:nvSpPr>
-          <p:cNvPr id="20" name="TextBox 19"/>
+      <p:pic>
+        <p:nvPicPr>
+          <p:cNvPr id="22" name="Picture 21" descr="dir_2.png"/>
+          <p:cNvPicPr>
+            <a:picLocks noChangeAspect="1"/>
+          </p:cNvPicPr>
+          <p:nvPr/>
+        </p:nvPicPr>
+        <p:blipFill>
+          <a:blip r:embed="rId4"/>
+          <a:stretch>
+            <a:fillRect/>
+          </a:stretch>
+        </p:blipFill>
+        <p:spPr>
+          <a:xfrm>
+            <a:off x="9966960" y="1371600"/>
+            <a:ext cx="1371600" cy="1371600"/>
+          </a:xfrm>
+          <a:prstGeom prst="rect">
+            <a:avLst/>
+          </a:prstGeom>
+        </p:spPr>
+      </p:pic>
+      <p:sp>
+        <p:nvSpPr>
+          <p:cNvPr id="23" name="TextBox 22"/>
           <p:cNvSpPr txBox="1"/>
           <p:nvPr/>
         </p:nvSpPr>
@@ -25412,7 +25484,7 @@
       </p:sp>
       <p:sp>
         <p:nvSpPr>
-          <p:cNvPr id="21" name="TextBox 20"/>
+          <p:cNvPr id="24" name="TextBox 23"/>
           <p:cNvSpPr txBox="1"/>
           <p:nvPr/>
         </p:nvSpPr>
@@ -25447,7 +25519,7 @@
       </p:sp>
       <p:sp>
         <p:nvSpPr>
-          <p:cNvPr id="22" name="Rectangle 21"/>
+          <p:cNvPr id="25" name="Rectangle 24"/>
           <p:cNvSpPr/>
           <p:nvPr/>
         </p:nvSpPr>
@@ -25490,7 +25562,7 @@
       </p:sp>
       <p:sp>
         <p:nvSpPr>
-          <p:cNvPr id="23" name="TextBox 22"/>
+          <p:cNvPr id="26" name="TextBox 25"/>
           <p:cNvSpPr txBox="1"/>
           <p:nvPr/>
         </p:nvSpPr>
@@ -25529,7 +25601,7 @@
       </p:sp>
       <p:sp>
         <p:nvSpPr>
-          <p:cNvPr id="24" name="Rectangle 23"/>
+          <p:cNvPr id="27" name="Rectangle 26"/>
           <p:cNvSpPr/>
           <p:nvPr/>
         </p:nvSpPr>
@@ -25570,9 +25642,33 @@
           </a:p>
         </p:txBody>
       </p:sp>
-      <p:sp>
-        <p:nvSpPr>
-          <p:cNvPr id="25" name="TextBox 24"/>
+      <p:pic>
+        <p:nvPicPr>
+          <p:cNvPr id="28" name="Picture 27" descr="dir_3.png"/>
+          <p:cNvPicPr>
+            <a:picLocks noChangeAspect="1"/>
+          </p:cNvPicPr>
+          <p:nvPr/>
+        </p:nvPicPr>
+        <p:blipFill>
+          <a:blip r:embed="rId5"/>
+          <a:stretch>
+            <a:fillRect/>
+          </a:stretch>
+        </p:blipFill>
+        <p:spPr>
+          <a:xfrm>
+            <a:off x="548640" y="4709160"/>
+            <a:ext cx="1371600" cy="1371600"/>
+          </a:xfrm>
+          <a:prstGeom prst="rect">
+            <a:avLst/>
+          </a:prstGeom>
+        </p:spPr>
+      </p:pic>
+      <p:sp>
+        <p:nvSpPr>
+          <p:cNvPr id="29" name="TextBox 28"/>
           <p:cNvSpPr txBox="1"/>
           <p:nvPr/>
         </p:nvSpPr>
@@ -25607,7 +25703,7 @@
       </p:sp>
       <p:sp>
         <p:nvSpPr>
-          <p:cNvPr id="26" name="TextBox 25"/>
+          <p:cNvPr id="30" name="TextBox 29"/>
           <p:cNvSpPr txBox="1"/>
           <p:nvPr/>
         </p:nvSpPr>
@@ -25642,7 +25738,7 @@
       </p:sp>
       <p:sp>
         <p:nvSpPr>
-          <p:cNvPr id="27" name="Rectangle 26"/>
+          <p:cNvPr id="31" name="Rectangle 30"/>
           <p:cNvSpPr/>
           <p:nvPr/>
         </p:nvSpPr>
@@ -25685,7 +25781,7 @@
       </p:sp>
       <p:sp>
         <p:nvSpPr>
-          <p:cNvPr id="28" name="TextBox 27"/>
+          <p:cNvPr id="32" name="TextBox 31"/>
           <p:cNvSpPr txBox="1"/>
           <p:nvPr/>
         </p:nvSpPr>
@@ -25724,7 +25820,7 @@
       </p:sp>
       <p:sp>
         <p:nvSpPr>
-          <p:cNvPr id="29" name="Rectangle 28"/>
+          <p:cNvPr id="33" name="Rectangle 32"/>
           <p:cNvSpPr/>
           <p:nvPr/>
         </p:nvSpPr>
@@ -25765,9 +25861,33 @@
           </a:p>
         </p:txBody>
       </p:sp>
-      <p:sp>
-        <p:nvSpPr>
-          <p:cNvPr id="30" name="TextBox 29"/>
+      <p:pic>
+        <p:nvPicPr>
+          <p:cNvPr id="34" name="Picture 33" descr="dir_4.png"/>
+          <p:cNvPicPr>
+            <a:picLocks noChangeAspect="1"/>
+          </p:cNvPicPr>
+          <p:nvPr/>
+        </p:nvPicPr>
+        <p:blipFill>
+          <a:blip r:embed="rId6"/>
+          <a:stretch>
+            <a:fillRect/>
+          </a:stretch>
+        </p:blipFill>
+        <p:spPr>
+          <a:xfrm>
+            <a:off x="5257800" y="4709160"/>
+            <a:ext cx="1371600" cy="1371600"/>
+          </a:xfrm>
+          <a:prstGeom prst="rect">
+            <a:avLst/>
+          </a:prstGeom>
+        </p:spPr>
+      </p:pic>
+      <p:sp>
+        <p:nvSpPr>
+          <p:cNvPr id="35" name="TextBox 34"/>
           <p:cNvSpPr txBox="1"/>
           <p:nvPr/>
         </p:nvSpPr>
@@ -25802,7 +25922,7 @@
       </p:sp>
       <p:sp>
         <p:nvSpPr>
-          <p:cNvPr id="31" name="TextBox 30"/>
+          <p:cNvPr id="36" name="TextBox 35"/>
           <p:cNvSpPr txBox="1"/>
           <p:nvPr/>
         </p:nvSpPr>
@@ -25837,7 +25957,7 @@
       </p:sp>
       <p:sp>
         <p:nvSpPr>
-          <p:cNvPr id="32" name="Rectangle 31"/>
+          <p:cNvPr id="37" name="Rectangle 36"/>
           <p:cNvSpPr/>
           <p:nvPr/>
         </p:nvSpPr>
@@ -25880,7 +26000,7 @@
       </p:sp>
       <p:sp>
         <p:nvSpPr>
-          <p:cNvPr id="33" name="TextBox 32"/>
+          <p:cNvPr id="38" name="TextBox 37"/>
           <p:cNvSpPr txBox="1"/>
           <p:nvPr/>
         </p:nvSpPr>
@@ -25919,7 +26039,7 @@
       </p:sp>
       <p:sp>
         <p:nvSpPr>
-          <p:cNvPr id="34" name="Rectangle 33"/>
+          <p:cNvPr id="39" name="Rectangle 38"/>
           <p:cNvSpPr/>
           <p:nvPr/>
         </p:nvSpPr>
@@ -25960,9 +26080,33 @@
           </a:p>
         </p:txBody>
       </p:sp>
-      <p:sp>
-        <p:nvSpPr>
-          <p:cNvPr id="35" name="TextBox 34"/>
+      <p:pic>
+        <p:nvPicPr>
+          <p:cNvPr id="40" name="Picture 39" descr="dir_5.png"/>
+          <p:cNvPicPr>
+            <a:picLocks noChangeAspect="1"/>
+          </p:cNvPicPr>
+          <p:nvPr/>
+        </p:nvPicPr>
+        <p:blipFill>
+          <a:blip r:embed="rId7"/>
+          <a:stretch>
+            <a:fillRect/>
+          </a:stretch>
+        </p:blipFill>
+        <p:spPr>
+          <a:xfrm>
+            <a:off x="9966960" y="4709160"/>
+            <a:ext cx="1371600" cy="1371600"/>
+          </a:xfrm>
+          <a:prstGeom prst="rect">
+            <a:avLst/>
+          </a:prstGeom>
+        </p:spPr>
+      </p:pic>
+      <p:sp>
+        <p:nvSpPr>
+          <p:cNvPr id="41" name="TextBox 40"/>
           <p:cNvSpPr txBox="1"/>
           <p:nvPr/>
         </p:nvSpPr>
@@ -25997,7 +26141,7 @@
       </p:sp>
       <p:sp>
         <p:nvSpPr>
-          <p:cNvPr id="36" name="TextBox 35"/>
+          <p:cNvPr id="42" name="TextBox 41"/>
           <p:cNvSpPr txBox="1"/>
           <p:nvPr/>
         </p:nvSpPr>
@@ -26032,7 +26176,7 @@
       </p:sp>
       <p:sp>
         <p:nvSpPr>
-          <p:cNvPr id="37" name="Rectangle 36"/>
+          <p:cNvPr id="43" name="Rectangle 42"/>
           <p:cNvSpPr/>
           <p:nvPr/>
         </p:nvSpPr>
@@ -26075,7 +26219,7 @@
       </p:sp>
       <p:sp>
         <p:nvSpPr>
-          <p:cNvPr id="38" name="TextBox 37"/>
+          <p:cNvPr id="44" name="TextBox 43"/>
           <p:cNvSpPr txBox="1"/>
           <p:nvPr/>
         </p:nvSpPr>
@@ -32198,6 +32342,30 @@
           </a:p>
         </p:txBody>
       </p:sp>
+      <p:pic>
+        <p:nvPicPr>
+          <p:cNvPr id="32" name="Picture 31" descr="02_embedded_laptop.jpg"/>
+          <p:cNvPicPr>
+            <a:picLocks noChangeAspect="1"/>
+          </p:cNvPicPr>
+          <p:nvPr/>
+        </p:nvPicPr>
+        <p:blipFill>
+          <a:blip r:embed="rId2"/>
+          <a:stretch>
+            <a:fillRect/>
+          </a:stretch>
+        </p:blipFill>
+        <p:spPr>
+          <a:xfrm>
+            <a:off x="8869680" y="1188720"/>
+            <a:ext cx="5486400" cy="6492240"/>
+          </a:xfrm>
+          <a:prstGeom prst="rect">
+            <a:avLst/>
+          </a:prstGeom>
+        </p:spPr>
+      </p:pic>
     </p:spTree>
   </p:cSld>
   <p:clrMapOvr>
@@ -33156,6 +33324,30 @@
           </a:p>
         </p:txBody>
       </p:sp>
+      <p:pic>
+        <p:nvPicPr>
+          <p:cNvPr id="26" name="Picture 25" descr="01_agent_saas_mobile.jpg"/>
+          <p:cNvPicPr>
+            <a:picLocks noChangeAspect="1"/>
+          </p:cNvPicPr>
+          <p:nvPr/>
+        </p:nvPicPr>
+        <p:blipFill>
+          <a:blip r:embed="rId2"/>
+          <a:stretch>
+            <a:fillRect/>
+          </a:stretch>
+        </p:blipFill>
+        <p:spPr>
+          <a:xfrm>
+            <a:off x="731520" y="4206240"/>
+            <a:ext cx="13167360" cy="3657600"/>
+          </a:xfrm>
+          <a:prstGeom prst="rect">
+            <a:avLst/>
+          </a:prstGeom>
+        </p:spPr>
+      </p:pic>
     </p:spTree>
   </p:cSld>
   <p:clrMapOvr>

</xml_diff>